<commit_message>
docs: update all client documents with latest features
- PPTX: updated Fase 1 slide with driver system, incidents, PDF reports,
  exact address collection; updated timeline and requirements slides
- DOCX/PDF proposal: added reports, driver system, and address collection
  to Fase 1 scope; updated budget breakdown
- Technical summary PDF: updated contact flow description to reflect
  exact address collection for route reorganization
</commit_message>
<xml_diff>
--- a/docs/GARYCIO_Presentacion.pptx
+++ b/docs/GARYCIO_Presentacion.pptx
@@ -7259,7 +7259,7 @@
               </a:buClr>
             </a:pPr>
             <a:r>
-              <a:t>Contacto automatico con donantes de zonas nuevas</a:t>
+              <a:t>Contacto automatico con donantes: confirma si donan, dias y direccion exacta</a:t>
             </a:r>
           </a:p>
           <a:p>
@@ -7279,7 +7279,7 @@
               </a:buClr>
             </a:pPr>
             <a:r>
-              <a:t>Presentacion del servicio y recoleccion de datos</a:t>
+              <a:t>Registro de datos y presentacion del servicio</a:t>
             </a:r>
           </a:p>
           <a:p>
@@ -7299,7 +7299,7 @@
               </a:buClr>
             </a:pPr>
             <a:r>
-              <a:t>Confirmacion de dias de recoleccion disponibles</a:t>
+              <a:t>Recoleccion de direccion exacta para reorganizar recorridos</a:t>
             </a:r>
           </a:p>
         </p:txBody>
@@ -7880,7 +7880,7 @@
               </a:buClr>
             </a:pPr>
             <a:r>
-              <a:t>Canal para avisos de donantes (no recoleccion, etc.)</a:t>
+              <a:t>Reporte de incidentes con alerta inmediata al CEO</a:t>
             </a:r>
           </a:p>
           <a:p>
@@ -7900,7 +7900,7 @@
               </a:buClr>
             </a:pPr>
             <a:r>
-              <a:t>Notificaciones automaticas al equipo</a:t>
+              <a:t>Reporte PDF diario a las 19:00 hs con estadisticas</a:t>
             </a:r>
           </a:p>
           <a:p>
@@ -7920,7 +7920,7 @@
               </a:buClr>
             </a:pPr>
             <a:r>
-              <a:t>Registro y seguimiento de cada caso</a:t>
+              <a:t>Registro de litros, bidones y combustible por chofer</a:t>
             </a:r>
           </a:p>
         </p:txBody>
@@ -12240,7 +12240,7 @@
               </a:defRPr>
             </a:pPr>
             <a:r>
-              <a:t>Numeros de telefono, direcciones, zonas asignadas y estado actual de cada donante.</a:t>
+              <a:t>Numeros de telefono, direcciones EXACTAS (calle, numero, entre calles, piso), zonas y estado de donacion actual.</a:t>
             </a:r>
           </a:p>
         </p:txBody>
@@ -12409,7 +12409,7 @@
               </a:defRPr>
             </a:pPr>
             <a:r>
-              <a:t>Detalle de las zonas recientemente asignadas: limites, donantes potenciales, contactos.</a:t>
+              <a:t>Detalle de zonas nuevas: limites, donantes potenciales. Confirmar si estan donando y que dia.</a:t>
             </a:r>
           </a:p>
         </p:txBody>
@@ -13330,7 +13330,7 @@
               </a:defRPr>
             </a:pPr>
             <a:r>
-              <a:t>Setup + Bot WhatsApp Basico</a:t>
+              <a:t>Bot WhatsApp + Choferes</a:t>
             </a:r>
           </a:p>
         </p:txBody>
@@ -13418,7 +13418,7 @@
               </a:buClr>
             </a:pPr>
             <a:r>
-              <a:t>Configuracion de infraestructura</a:t>
+              <a:t>Bot con 7 flujos operativos</a:t>
             </a:r>
           </a:p>
           <a:p>
@@ -13438,7 +13438,7 @@
               </a:buClr>
             </a:pPr>
             <a:r>
-              <a:t>Bot WhatsApp: flujo de presentacion</a:t>
+              <a:t>Sistema de choferes e incidentes</a:t>
             </a:r>
           </a:p>
           <a:p>
@@ -13458,7 +13458,7 @@
               </a:buClr>
             </a:pPr>
             <a:r>
-              <a:t>Integracion con WhatsApp Business API</a:t>
+              <a:t>Reportes PDF diarios automaticos</a:t>
             </a:r>
           </a:p>
         </p:txBody>
@@ -13697,7 +13697,7 @@
               </a:buClr>
             </a:pPr>
             <a:r>
-              <a:t>Envio masivo personalizado a donantes</a:t>
+              <a:t>Contacto masivo a nuevas zonas</a:t>
             </a:r>
           </a:p>
           <a:p>
@@ -13717,7 +13717,7 @@
               </a:buClr>
             </a:pPr>
             <a:r>
-              <a:t>Recoleccion de datos (dias, estado)</a:t>
+              <a:t>Recoleccion de direccion exacta</a:t>
             </a:r>
           </a:p>
           <a:p>
@@ -13737,7 +13737,7 @@
               </a:buClr>
             </a:pPr>
             <a:r>
-              <a:t>Base de datos de donantes activos</a:t>
+              <a:t>Base de datos + migracion datos</a:t>
             </a:r>
           </a:p>
         </p:txBody>

</xml_diff>